<commit_message>
Fix training-time logging + regenerate graphs & README
</commit_message>
<xml_diff>
--- a/Component-Detection-YOLO11.pptx
+++ b/Component-Detection-YOLO11.pptx
@@ -4,6 +4,9 @@
   <p:sldMasterIdLst>
     <p:sldMasterId id="2147483648" r:id="rId1"/>
   </p:sldMasterIdLst>
+  <p:notesMasterIdLst>
+    <p:notesMasterId r:id="rId17"/>
+  </p:notesMasterIdLst>
   <p:sldIdLst>
     <p:sldId id="256" r:id="rId2"/>
     <p:sldId id="257" r:id="rId3"/>
@@ -21,9 +24,6 @@
     <p:sldId id="269" r:id="rId15"/>
     <p:sldId id="270" r:id="rId16"/>
   </p:sldIdLst>
-  <p:notesMasterIdLst>
-    <p:notesMasterId r:id="rId17"/>
-  </p:notesMasterIdLst>
   <p:sldSz cx="12192000" cy="6858000"/>
   <p:notesSz cx="6858000" cy="12192000"/>
   <p:defaultTextStyle>
@@ -118,6 +118,11 @@
       </a:defRPr>
     </a:lvl9pPr>
   </p:defaultTextStyle>
+  <p:extLst>
+    <p:ext uri="{EFAFB233-063F-42B5-8137-9DF3F51BA10A}">
+      <p15:sldGuideLst xmlns:p15="http://schemas.microsoft.com/office/powerpoint/2012/main"/>
+    </p:ext>
+  </p:extLst>
 </p:presentation>
 </file>
 
@@ -143,234 +148,10 @@
           <a:chExt cx="0" cy="0"/>
         </a:xfrm>
       </p:grpSpPr>
-      <p:sp>
-        <p:nvSpPr>
-          <p:cNvPr id="2" name="Header Placeholder 1"/>
-          <p:cNvSpPr>
-            <a:spLocks noGrp="1"/>
-          </p:cNvSpPr>
-          <p:nvPr>
-            <p:ph type="hdr" sz="quarter"/>
-          </p:nvPr>
-        </p:nvSpPr>
-        <p:spPr>
-          <a:xfrm>
-            <a:off x="0" y="0"/>
-            <a:ext cx="2971800" cy="458788"/>
-          </a:xfrm>
-          <a:prstGeom prst="rect">
-            <a:avLst/>
-          </a:prstGeom>
-        </p:spPr>
-        <p:txBody>
-          <a:bodyPr vert="horz" lIns="91440" tIns="45720" rIns="91440" bIns="45720" rtlCol="0"/>
-          <a:lstStyle>
-            <a:lvl1pPr algn="l">
-              <a:defRPr sz="1200"/>
-            </a:lvl1pPr>
-          </a:lstStyle>
-          <a:p>
-            <a:endParaRPr lang="en-US"/>
-          </a:p>
-        </p:txBody>
-      </p:sp>
-      <p:sp>
-        <p:nvSpPr>
-          <p:cNvPr id="3" name="Date Placeholder 2"/>
-          <p:cNvSpPr>
-            <a:spLocks noGrp="1"/>
-          </p:cNvSpPr>
-          <p:nvPr>
-            <p:ph type="dt" idx="1"/>
-          </p:nvPr>
-        </p:nvSpPr>
-        <p:spPr>
-          <a:xfrm>
-            <a:off x="3884613" y="0"/>
-            <a:ext cx="2971800" cy="458788"/>
-          </a:xfrm>
-          <a:prstGeom prst="rect">
-            <a:avLst/>
-          </a:prstGeom>
-        </p:spPr>
-        <p:txBody>
-          <a:bodyPr vert="horz" lIns="91440" tIns="45720" rIns="91440" bIns="45720" rtlCol="0"/>
-          <a:lstStyle>
-            <a:lvl1pPr algn="r">
-              <a:defRPr sz="1200"/>
-            </a:lvl1pPr>
-          </a:lstStyle>
-          <a:p>
-            <a:fld id="{5282F153-3F37-0F45-9E97-73ACFA13230C}" type="datetimeFigureOut">
-              <a:rPr lang="en-US"/>
-              <a:t>7/23/19</a:t>
-            </a:fld>
-            <a:endParaRPr lang="en-US"/>
-          </a:p>
-        </p:txBody>
-      </p:sp>
-      <p:sp>
-        <p:nvSpPr>
-          <p:cNvPr id="4" name="Slide Image Placeholder 3"/>
-          <p:cNvSpPr>
-            <a:spLocks noGrp="1" noRot="1" noChangeAspect="1"/>
-          </p:cNvSpPr>
-          <p:nvPr>
-            <p:ph type="sldImg" idx="2"/>
-          </p:nvPr>
-        </p:nvSpPr>
-        <p:spPr>
-          <a:xfrm>
-            <a:off x="685800" y="1143000"/>
-            <a:ext cx="5486400" cy="3086100"/>
-          </a:xfrm>
-          <a:prstGeom prst="rect">
-            <a:avLst/>
-          </a:prstGeom>
-          <a:noFill/>
-          <a:ln w="12700">
-            <a:solidFill>
-              <a:prstClr val="black"/>
-            </a:solidFill>
-          </a:ln>
-        </p:spPr>
-        <p:txBody>
-          <a:bodyPr vert="horz" lIns="91440" tIns="45720" rIns="91440" bIns="45720" rtlCol="0" anchor="ctr"/>
-          <a:lstStyle/>
-          <a:p>
-            <a:endParaRPr lang="en-US"/>
-          </a:p>
-        </p:txBody>
-      </p:sp>
-      <p:sp>
-        <p:nvSpPr>
-          <p:cNvPr id="5" name="Notes Placeholder 4"/>
-          <p:cNvSpPr>
-            <a:spLocks noGrp="1"/>
-          </p:cNvSpPr>
-          <p:nvPr>
-            <p:ph type="body" sz="quarter" idx="3"/>
-          </p:nvPr>
-        </p:nvSpPr>
-        <p:spPr>
-          <a:xfrm>
-            <a:off x="685800" y="4400550"/>
-            <a:ext cx="5486400" cy="3600450"/>
-          </a:xfrm>
-          <a:prstGeom prst="rect">
-            <a:avLst/>
-          </a:prstGeom>
-        </p:spPr>
-        <p:txBody>
-          <a:bodyPr vert="horz" lIns="91440" tIns="45720" rIns="91440" bIns="45720" rtlCol="0"/>
-          <a:lstStyle/>
-          <a:p>
-            <a:pPr lvl="0"/>
-            <a:r>
-              <a:rPr lang="en-US"/>
-              <a:t>Click to edit Master text styles</a:t>
-            </a:r>
-          </a:p>
-          <a:p>
-            <a:pPr lvl="1"/>
-            <a:r>
-              <a:rPr lang="en-US"/>
-              <a:t>Second level</a:t>
-            </a:r>
-          </a:p>
-          <a:p>
-            <a:pPr lvl="2"/>
-            <a:r>
-              <a:rPr lang="en-US"/>
-              <a:t>Third level</a:t>
-            </a:r>
-          </a:p>
-          <a:p>
-            <a:pPr lvl="3"/>
-            <a:r>
-              <a:rPr lang="en-US"/>
-              <a:t>Fourth level</a:t>
-            </a:r>
-          </a:p>
-          <a:p>
-            <a:pPr lvl="4"/>
-            <a:r>
-              <a:rPr lang="en-US"/>
-              <a:t>Fifth level</a:t>
-            </a:r>
-          </a:p>
-        </p:txBody>
-      </p:sp>
-      <p:sp>
-        <p:nvSpPr>
-          <p:cNvPr id="6" name="Footer Placeholder 5"/>
-          <p:cNvSpPr>
-            <a:spLocks noGrp="1"/>
-          </p:cNvSpPr>
-          <p:nvPr>
-            <p:ph type="ftr" sz="quarter" idx="4"/>
-          </p:nvPr>
-        </p:nvSpPr>
-        <p:spPr>
-          <a:xfrm>
-            <a:off x="0" y="8685213"/>
-            <a:ext cx="2971800" cy="458787"/>
-          </a:xfrm>
-          <a:prstGeom prst="rect">
-            <a:avLst/>
-          </a:prstGeom>
-        </p:spPr>
-        <p:txBody>
-          <a:bodyPr vert="horz" lIns="91440" tIns="45720" rIns="91440" bIns="45720" rtlCol="0" anchor="b"/>
-          <a:lstStyle>
-            <a:lvl1pPr algn="l">
-              <a:defRPr sz="1200"/>
-            </a:lvl1pPr>
-          </a:lstStyle>
-          <a:p>
-            <a:endParaRPr lang="en-US"/>
-          </a:p>
-        </p:txBody>
-      </p:sp>
-      <p:sp>
-        <p:nvSpPr>
-          <p:cNvPr id="7" name="Slide Number Placeholder 6"/>
-          <p:cNvSpPr>
-            <a:spLocks noGrp="1"/>
-          </p:cNvSpPr>
-          <p:nvPr>
-            <p:ph type="sldNum" sz="quarter" idx="5"/>
-          </p:nvPr>
-        </p:nvSpPr>
-        <p:spPr>
-          <a:xfrm>
-            <a:off x="3884613" y="8685213"/>
-            <a:ext cx="2971800" cy="458787"/>
-          </a:xfrm>
-          <a:prstGeom prst="rect">
-            <a:avLst/>
-          </a:prstGeom>
-        </p:spPr>
-        <p:txBody>
-          <a:bodyPr vert="horz" lIns="91440" tIns="45720" rIns="91440" bIns="45720" rtlCol="0" anchor="b"/>
-          <a:lstStyle>
-            <a:lvl1pPr algn="r">
-              <a:defRPr sz="1200"/>
-            </a:lvl1pPr>
-          </a:lstStyle>
-          <a:p>
-            <a:fld id="{CE5E9CC1-C706-0F49-92D6-E571CC5EEA8F}" type="slidenum">
-              <a:rPr lang="en-US"/>
-              <a:t>‹#›</a:t>
-            </a:fld>
-            <a:endParaRPr lang="en-US"/>
-          </a:p>
-        </p:txBody>
-      </p:sp>
     </p:spTree>
     <p:extLst>
       <p:ext uri="{BB962C8B-B14F-4D97-AF65-F5344CB8AC3E}">
-        <p14:creationId xmlns:p14="http://schemas.microsoft.com/office/powerpoint/2010/main" val="1024086991"/>
+        <p14:creationId xmlns:p14="http://schemas.microsoft.com/office/powerpoint/2010/main" val="293630904"/>
       </p:ext>
     </p:extLst>
   </p:cSld>
@@ -514,10 +295,6 @@
           <a:bodyPr/>
           <a:lstStyle/>
           <a:p>
-            <a:r>
-              <a:rPr lang="en-US" dirty="0"/>
-              <a:t/>
-            </a:r>
             <a:endParaRPr lang="en-US" dirty="0"/>
           </a:p>
         </p:txBody>
@@ -602,10 +379,6 @@
           <a:bodyPr/>
           <a:lstStyle/>
           <a:p>
-            <a:r>
-              <a:rPr lang="en-US" dirty="0"/>
-              <a:t/>
-            </a:r>
             <a:endParaRPr lang="en-US" dirty="0"/>
           </a:p>
         </p:txBody>
@@ -690,10 +463,6 @@
           <a:bodyPr/>
           <a:lstStyle/>
           <a:p>
-            <a:r>
-              <a:rPr lang="en-US" dirty="0"/>
-              <a:t/>
-            </a:r>
             <a:endParaRPr lang="en-US" dirty="0"/>
           </a:p>
         </p:txBody>
@@ -778,10 +547,6 @@
           <a:bodyPr/>
           <a:lstStyle/>
           <a:p>
-            <a:r>
-              <a:rPr lang="en-US" dirty="0"/>
-              <a:t/>
-            </a:r>
             <a:endParaRPr lang="en-US" dirty="0"/>
           </a:p>
         </p:txBody>
@@ -866,10 +631,6 @@
           <a:bodyPr/>
           <a:lstStyle/>
           <a:p>
-            <a:r>
-              <a:rPr lang="en-US" dirty="0"/>
-              <a:t/>
-            </a:r>
             <a:endParaRPr lang="en-US" dirty="0"/>
           </a:p>
         </p:txBody>
@@ -954,10 +715,6 @@
           <a:bodyPr/>
           <a:lstStyle/>
           <a:p>
-            <a:r>
-              <a:rPr lang="en-US" dirty="0"/>
-              <a:t/>
-            </a:r>
             <a:endParaRPr lang="en-US" dirty="0"/>
           </a:p>
         </p:txBody>
@@ -1042,10 +799,6 @@
           <a:bodyPr/>
           <a:lstStyle/>
           <a:p>
-            <a:r>
-              <a:rPr lang="en-US" dirty="0"/>
-              <a:t/>
-            </a:r>
             <a:endParaRPr lang="en-US" dirty="0"/>
           </a:p>
         </p:txBody>
@@ -1130,10 +883,6 @@
           <a:bodyPr/>
           <a:lstStyle/>
           <a:p>
-            <a:r>
-              <a:rPr lang="en-US" dirty="0"/>
-              <a:t/>
-            </a:r>
             <a:endParaRPr lang="en-US" dirty="0"/>
           </a:p>
         </p:txBody>
@@ -1218,10 +967,6 @@
           <a:bodyPr/>
           <a:lstStyle/>
           <a:p>
-            <a:r>
-              <a:rPr lang="en-US" dirty="0"/>
-              <a:t/>
-            </a:r>
             <a:endParaRPr lang="en-US" dirty="0"/>
           </a:p>
         </p:txBody>
@@ -1306,10 +1051,6 @@
           <a:bodyPr/>
           <a:lstStyle/>
           <a:p>
-            <a:r>
-              <a:rPr lang="en-US" dirty="0"/>
-              <a:t/>
-            </a:r>
             <a:endParaRPr lang="en-US" dirty="0"/>
           </a:p>
         </p:txBody>
@@ -1394,10 +1135,6 @@
           <a:bodyPr/>
           <a:lstStyle/>
           <a:p>
-            <a:r>
-              <a:rPr lang="en-US" dirty="0"/>
-              <a:t/>
-            </a:r>
             <a:endParaRPr lang="en-US" dirty="0"/>
           </a:p>
         </p:txBody>
@@ -1482,10 +1219,6 @@
           <a:bodyPr/>
           <a:lstStyle/>
           <a:p>
-            <a:r>
-              <a:rPr lang="en-US" dirty="0"/>
-              <a:t/>
-            </a:r>
             <a:endParaRPr lang="en-US" dirty="0"/>
           </a:p>
         </p:txBody>
@@ -1570,10 +1303,6 @@
           <a:bodyPr/>
           <a:lstStyle/>
           <a:p>
-            <a:r>
-              <a:rPr lang="en-US" dirty="0"/>
-              <a:t/>
-            </a:r>
             <a:endParaRPr lang="en-US" dirty="0"/>
           </a:p>
         </p:txBody>
@@ -1658,10 +1387,6 @@
           <a:bodyPr/>
           <a:lstStyle/>
           <a:p>
-            <a:r>
-              <a:rPr lang="en-US" dirty="0"/>
-              <a:t/>
-            </a:r>
             <a:endParaRPr lang="en-US" dirty="0"/>
           </a:p>
         </p:txBody>
@@ -1746,10 +1471,6 @@
           <a:bodyPr/>
           <a:lstStyle/>
           <a:p>
-            <a:r>
-              <a:rPr lang="en-US" dirty="0"/>
-              <a:t/>
-            </a:r>
             <a:endParaRPr lang="en-US" dirty="0"/>
           </a:p>
         </p:txBody>
@@ -1823,6 +1544,11 @@
 <file path=ppt/slideMasters/slideMaster1.xml><?xml version="1.0" encoding="utf-8"?>
 <p:sldMaster xmlns:a="http://schemas.openxmlformats.org/drawingml/2006/main" xmlns:r="http://schemas.openxmlformats.org/officeDocument/2006/relationships" xmlns:p="http://schemas.openxmlformats.org/presentationml/2006/main">
   <p:cSld>
+    <p:bg>
+      <p:bgRef idx="1001">
+        <a:schemeClr val="bg1"/>
+      </p:bgRef>
+    </p:bg>
     <p:spTree>
       <p:nvGrpSpPr>
         <p:cNvPr id="1" name=""/>
@@ -2105,6 +1831,7 @@
         <a:solidFill>
           <a:srgbClr val="0F172A"/>
         </a:solidFill>
+        <a:effectLst/>
       </p:bgPr>
     </p:bg>
     <p:spTree>
@@ -2162,11 +1889,11 @@
           <a:bodyPr wrap="square" rtlCol="0" anchor="ctr"/>
           <a:lstStyle/>
           <a:p>
-            <a:pPr indent="0" marL="0">
+            <a:pPr marL="0" indent="0">
               <a:buNone/>
             </a:pPr>
             <a:r>
-              <a:rPr lang="en-US" sz="1300" spc="200" kern="0" dirty="0">
+              <a:rPr lang="en-US" sz="1300" kern="0" spc="200" dirty="0">
                 <a:solidFill>
                   <a:srgbClr val="06B6D4"/>
                 </a:solidFill>
@@ -2201,7 +1928,7 @@
           <a:bodyPr wrap="square" rtlCol="0" anchor="ctr"/>
           <a:lstStyle/>
           <a:p>
-            <a:pPr indent="0" marL="0">
+            <a:pPr marL="0" indent="0">
               <a:lnSpc>
                 <a:spcPct val="102000"/>
               </a:lnSpc>
@@ -2221,7 +1948,7 @@
             <a:endParaRPr lang="en-US" sz="4000" dirty="0"/>
           </a:p>
           <a:p>
-            <a:pPr indent="0" marL="0">
+            <a:pPr marL="0" indent="0">
               <a:lnSpc>
                 <a:spcPct val="102000"/>
               </a:lnSpc>
@@ -2263,7 +1990,7 @@
           <a:bodyPr wrap="square" rtlCol="0" anchor="ctr"/>
           <a:lstStyle/>
           <a:p>
-            <a:pPr indent="0" marL="0">
+            <a:pPr marL="0" indent="0">
               <a:buNone/>
             </a:pPr>
             <a:r>
@@ -2302,7 +2029,7 @@
           <a:bodyPr wrap="square" rtlCol="0" anchor="ctr"/>
           <a:lstStyle/>
           <a:p>
-            <a:pPr indent="0" marL="0">
+            <a:pPr marL="0" indent="0">
               <a:buNone/>
             </a:pPr>
             <a:r>
@@ -2336,6 +2063,7 @@
         <a:solidFill>
           <a:srgbClr val="FFFFFF"/>
         </a:solidFill>
+        <a:effectLst/>
       </p:bgPr>
     </p:bg>
     <p:spTree>
@@ -2393,7 +2121,7 @@
           <a:bodyPr wrap="square" lIns="0" tIns="0" rIns="0" bIns="0" rtlCol="0" anchor="ctr"/>
           <a:lstStyle/>
           <a:p>
-            <a:pPr indent="0" marL="0">
+            <a:pPr marL="0" indent="0">
               <a:buNone/>
             </a:pPr>
             <a:r>
@@ -2432,7 +2160,7 @@
           <a:bodyPr wrap="square" rtlCol="0" anchor="ctr"/>
           <a:lstStyle/>
           <a:p>
-            <a:pPr algn="r" indent="0" marL="0">
+            <a:pPr marL="0" indent="0" algn="r">
               <a:buNone/>
             </a:pPr>
             <a:r>
@@ -2498,7 +2226,7 @@
           <a:bodyPr wrap="square" rtlCol="0" anchor="ctr"/>
           <a:lstStyle/>
           <a:p>
-            <a:pPr algn="ctr" indent="0" marL="0">
+            <a:pPr marL="0" indent="0" algn="ctr">
               <a:buNone/>
             </a:pPr>
             <a:r>
@@ -2537,7 +2265,7 @@
           <a:bodyPr wrap="square" rtlCol="0" anchor="ctr"/>
           <a:lstStyle/>
           <a:p>
-            <a:pPr algn="ctr" indent="0" marL="0">
+            <a:pPr marL="0" indent="0" algn="ctr">
               <a:buNone/>
             </a:pPr>
             <a:r>
@@ -2576,7 +2304,7 @@
           <a:bodyPr wrap="square" rtlCol="0" anchor="ctr"/>
           <a:lstStyle/>
           <a:p>
-            <a:pPr algn="ctr" indent="0" marL="0">
+            <a:pPr marL="0" indent="0" algn="ctr">
               <a:buNone/>
             </a:pPr>
             <a:r>
@@ -2615,7 +2343,7 @@
           <a:bodyPr wrap="square" rtlCol="0" anchor="ctr"/>
           <a:lstStyle/>
           <a:p>
-            <a:pPr algn="ctr" indent="0" marL="0">
+            <a:pPr marL="0" indent="0" algn="ctr">
               <a:buNone/>
             </a:pPr>
             <a:r>
@@ -2649,6 +2377,7 @@
         <a:solidFill>
           <a:srgbClr val="FFFFFF"/>
         </a:solidFill>
+        <a:effectLst/>
       </p:bgPr>
     </p:bg>
     <p:spTree>
@@ -2706,7 +2435,7 @@
           <a:bodyPr wrap="square" lIns="0" tIns="0" rIns="0" bIns="0" rtlCol="0" anchor="ctr"/>
           <a:lstStyle/>
           <a:p>
-            <a:pPr indent="0" marL="0">
+            <a:pPr marL="0" indent="0">
               <a:buNone/>
             </a:pPr>
             <a:r>
@@ -2745,7 +2474,7 @@
           <a:bodyPr wrap="square" rtlCol="0" anchor="ctr"/>
           <a:lstStyle/>
           <a:p>
-            <a:pPr algn="r" indent="0" marL="0">
+            <a:pPr marL="0" indent="0" algn="r">
               <a:buNone/>
             </a:pPr>
             <a:r>
@@ -2811,7 +2540,7 @@
           <a:bodyPr wrap="square" rtlCol="0" anchor="ctr"/>
           <a:lstStyle/>
           <a:p>
-            <a:pPr algn="ctr" indent="0" marL="0">
+            <a:pPr marL="0" indent="0" algn="ctr">
               <a:buNone/>
             </a:pPr>
             <a:r>
@@ -2850,7 +2579,7 @@
           <a:bodyPr wrap="square" rtlCol="0" anchor="ctr"/>
           <a:lstStyle/>
           <a:p>
-            <a:pPr algn="ctr" indent="0" marL="0">
+            <a:pPr marL="0" indent="0" algn="ctr">
               <a:buNone/>
             </a:pPr>
             <a:r>
@@ -2889,7 +2618,7 @@
           <a:bodyPr wrap="square" rtlCol="0" anchor="ctr"/>
           <a:lstStyle/>
           <a:p>
-            <a:pPr algn="ctr" indent="0" marL="0">
+            <a:pPr marL="0" indent="0" algn="ctr">
               <a:buNone/>
             </a:pPr>
             <a:r>
@@ -2928,7 +2657,7 @@
           <a:bodyPr wrap="square" rtlCol="0" anchor="ctr"/>
           <a:lstStyle/>
           <a:p>
-            <a:pPr algn="ctr" indent="0" marL="0">
+            <a:pPr marL="0" indent="0" algn="ctr">
               <a:buNone/>
             </a:pPr>
             <a:r>
@@ -2962,6 +2691,7 @@
         <a:solidFill>
           <a:srgbClr val="FFFFFF"/>
         </a:solidFill>
+        <a:effectLst/>
       </p:bgPr>
     </p:bg>
     <p:spTree>
@@ -3019,7 +2749,7 @@
           <a:bodyPr wrap="square" lIns="0" tIns="0" rIns="0" bIns="0" rtlCol="0" anchor="ctr"/>
           <a:lstStyle/>
           <a:p>
-            <a:pPr indent="0" marL="0">
+            <a:pPr marL="0" indent="0">
               <a:buNone/>
             </a:pPr>
             <a:r>
@@ -3058,7 +2788,7 @@
           <a:bodyPr wrap="square" rtlCol="0" anchor="ctr"/>
           <a:lstStyle/>
           <a:p>
-            <a:pPr algn="r" indent="0" marL="0">
+            <a:pPr marL="0" indent="0" algn="r">
               <a:buNone/>
             </a:pPr>
             <a:r>
@@ -3124,7 +2854,7 @@
           <a:bodyPr wrap="square" rtlCol="0" anchor="ctr"/>
           <a:lstStyle/>
           <a:p>
-            <a:pPr algn="ctr" indent="0" marL="0">
+            <a:pPr marL="0" indent="0" algn="ctr">
               <a:buNone/>
             </a:pPr>
             <a:r>
@@ -3163,7 +2893,7 @@
           <a:bodyPr wrap="square" rtlCol="0" anchor="ctr"/>
           <a:lstStyle/>
           <a:p>
-            <a:pPr algn="ctr" indent="0" marL="0">
+            <a:pPr marL="0" indent="0" algn="ctr">
               <a:buNone/>
             </a:pPr>
             <a:r>
@@ -3202,7 +2932,7 @@
           <a:bodyPr wrap="square" rtlCol="0" anchor="ctr"/>
           <a:lstStyle/>
           <a:p>
-            <a:pPr algn="ctr" indent="0" marL="0">
+            <a:pPr marL="0" indent="0" algn="ctr">
               <a:buNone/>
             </a:pPr>
             <a:r>
@@ -3241,7 +2971,7 @@
           <a:bodyPr wrap="square" rtlCol="0" anchor="ctr"/>
           <a:lstStyle/>
           <a:p>
-            <a:pPr algn="ctr" indent="0" marL="0">
+            <a:pPr marL="0" indent="0" algn="ctr">
               <a:buNone/>
             </a:pPr>
             <a:r>
@@ -3275,6 +3005,7 @@
         <a:solidFill>
           <a:srgbClr val="FFFFFF"/>
         </a:solidFill>
+        <a:effectLst/>
       </p:bgPr>
     </p:bg>
     <p:spTree>
@@ -3332,7 +3063,7 @@
           <a:bodyPr wrap="square" lIns="0" tIns="0" rIns="0" bIns="0" rtlCol="0" anchor="ctr"/>
           <a:lstStyle/>
           <a:p>
-            <a:pPr indent="0" marL="0">
+            <a:pPr marL="0" indent="0">
               <a:buNone/>
             </a:pPr>
             <a:r>
@@ -3371,7 +3102,7 @@
           <a:bodyPr wrap="square" rtlCol="0" anchor="ctr"/>
           <a:lstStyle/>
           <a:p>
-            <a:pPr algn="r" indent="0" marL="0">
+            <a:pPr marL="0" indent="0" algn="r">
               <a:buNone/>
             </a:pPr>
             <a:r>
@@ -3437,7 +3168,7 @@
           <a:bodyPr wrap="square" rtlCol="0" anchor="ctr"/>
           <a:lstStyle/>
           <a:p>
-            <a:pPr algn="ctr" indent="0" marL="0">
+            <a:pPr marL="0" indent="0" algn="ctr">
               <a:buNone/>
             </a:pPr>
             <a:r>
@@ -3476,7 +3207,7 @@
           <a:bodyPr wrap="square" rtlCol="0" anchor="ctr"/>
           <a:lstStyle/>
           <a:p>
-            <a:pPr algn="ctr" indent="0" marL="0">
+            <a:pPr marL="0" indent="0" algn="ctr">
               <a:buNone/>
             </a:pPr>
             <a:r>
@@ -3515,7 +3246,7 @@
           <a:bodyPr wrap="square" rtlCol="0" anchor="ctr"/>
           <a:lstStyle/>
           <a:p>
-            <a:pPr algn="ctr" indent="0" marL="0">
+            <a:pPr marL="0" indent="0" algn="ctr">
               <a:buNone/>
             </a:pPr>
             <a:r>
@@ -3554,7 +3285,7 @@
           <a:bodyPr wrap="square" rtlCol="0" anchor="ctr"/>
           <a:lstStyle/>
           <a:p>
-            <a:pPr algn="ctr" indent="0" marL="0">
+            <a:pPr marL="0" indent="0" algn="ctr">
               <a:buNone/>
             </a:pPr>
             <a:r>
@@ -3588,6 +3319,7 @@
         <a:solidFill>
           <a:srgbClr val="0F172A"/>
         </a:solidFill>
+        <a:effectLst/>
       </p:bgPr>
     </p:bg>
     <p:spTree>
@@ -3645,7 +3377,7 @@
           <a:bodyPr wrap="square" rtlCol="0" anchor="ctr"/>
           <a:lstStyle/>
           <a:p>
-            <a:pPr indent="0" marL="0">
+            <a:pPr marL="0" indent="0">
               <a:buNone/>
             </a:pPr>
             <a:r>
@@ -3684,7 +3416,7 @@
           <a:bodyPr wrap="square" rtlCol="0" anchor="ctr"/>
           <a:lstStyle/>
           <a:p>
-            <a:pPr indent="0" marL="0">
+            <a:pPr marL="0" indent="0">
               <a:buNone/>
             </a:pPr>
             <a:r>
@@ -3750,7 +3482,7 @@
           <a:bodyPr wrap="square" rtlCol="0" anchor="ctr"/>
           <a:lstStyle/>
           <a:p>
-            <a:pPr indent="0" marL="0">
+            <a:pPr marL="0" indent="0">
               <a:buNone/>
             </a:pPr>
             <a:r>
@@ -3764,9 +3496,6 @@
               </a:rPr>
               <a:t>GitHub:  </a:t>
             </a:r>
-            <a:pPr indent="0" marL="0">
-              <a:buNone/>
-            </a:pPr>
             <a:r>
               <a:rPr lang="en-US" sz="1500" b="1" dirty="0">
                 <a:solidFill>
@@ -3803,7 +3532,7 @@
           <a:bodyPr wrap="square" rtlCol="0" anchor="t"/>
           <a:lstStyle/>
           <a:p>
-            <a:pPr indent="0" marL="0">
+            <a:pPr marL="0" indent="0">
               <a:lnSpc>
                 <a:spcPct val="130000"/>
               </a:lnSpc>
@@ -3823,7 +3552,7 @@
             <a:endParaRPr lang="en-US" sz="1300" dirty="0"/>
           </a:p>
           <a:p>
-            <a:pPr indent="0" marL="0">
+            <a:pPr marL="0" indent="0">
               <a:lnSpc>
                 <a:spcPct val="130000"/>
               </a:lnSpc>
@@ -3843,7 +3572,7 @@
             <a:endParaRPr lang="en-US" sz="1300" dirty="0"/>
           </a:p>
           <a:p>
-            <a:pPr indent="0" marL="0">
+            <a:pPr marL="0" indent="0">
               <a:lnSpc>
                 <a:spcPct val="130000"/>
               </a:lnSpc>
@@ -3885,7 +3614,7 @@
           <a:bodyPr wrap="square" rtlCol="0" anchor="ctr"/>
           <a:lstStyle/>
           <a:p>
-            <a:pPr indent="0" marL="0">
+            <a:pPr marL="0" indent="0">
               <a:buNone/>
             </a:pPr>
             <a:r>
@@ -3919,6 +3648,7 @@
         <a:solidFill>
           <a:srgbClr val="0F172A"/>
         </a:solidFill>
+        <a:effectLst/>
       </p:bgPr>
     </p:bg>
     <p:spTree>
@@ -3976,7 +3706,7 @@
           <a:bodyPr wrap="square" rtlCol="0" anchor="ctr"/>
           <a:lstStyle/>
           <a:p>
-            <a:pPr indent="0" marL="0">
+            <a:pPr marL="0" indent="0">
               <a:buNone/>
             </a:pPr>
             <a:r>
@@ -4015,7 +3745,7 @@
           <a:bodyPr wrap="square" rtlCol="0" anchor="t"/>
           <a:lstStyle/>
           <a:p>
-            <a:pPr indent="0" marL="0">
+            <a:pPr marL="0" indent="0">
               <a:lnSpc>
                 <a:spcPct val="115000"/>
               </a:lnSpc>
@@ -4124,7 +3854,7 @@
           <a:bodyPr wrap="square" rtlCol="0" anchor="t"/>
           <a:lstStyle/>
           <a:p>
-            <a:pPr indent="0" marL="0">
+            <a:pPr marL="0" indent="0">
               <a:lnSpc>
                 <a:spcPct val="115000"/>
               </a:lnSpc>
@@ -4233,7 +3963,7 @@
           <a:bodyPr wrap="square" rtlCol="0" anchor="ctr"/>
           <a:lstStyle/>
           <a:p>
-            <a:pPr indent="0" marL="0">
+            <a:pPr marL="0" indent="0">
               <a:buNone/>
             </a:pPr>
             <a:r>
@@ -4267,6 +3997,7 @@
         <a:solidFill>
           <a:srgbClr val="FFFFFF"/>
         </a:solidFill>
+        <a:effectLst/>
       </p:bgPr>
     </p:bg>
     <p:spTree>
@@ -4324,7 +4055,7 @@
           <a:bodyPr wrap="square" lIns="0" tIns="0" rIns="0" bIns="0" rtlCol="0" anchor="ctr"/>
           <a:lstStyle/>
           <a:p>
-            <a:pPr indent="0" marL="0">
+            <a:pPr marL="0" indent="0">
               <a:buNone/>
             </a:pPr>
             <a:r>
@@ -4363,7 +4094,7 @@
           <a:bodyPr wrap="square" rtlCol="0" anchor="ctr"/>
           <a:lstStyle/>
           <a:p>
-            <a:pPr algn="r" indent="0" marL="0">
+            <a:pPr marL="0" indent="0" algn="r">
               <a:buNone/>
             </a:pPr>
             <a:r>
@@ -4402,7 +4133,7 @@
           <a:bodyPr wrap="square" rtlCol="0" anchor="t"/>
           <a:lstStyle/>
           <a:p>
-            <a:pPr indent="0" marL="0">
+            <a:pPr marL="0" indent="0">
               <a:lnSpc>
                 <a:spcPct val="110000"/>
               </a:lnSpc>
@@ -4423,7 +4154,7 @@
             <a:endParaRPr lang="en-US" sz="1500" dirty="0"/>
           </a:p>
           <a:p>
-            <a:pPr indent="0" marL="0">
+            <a:pPr marL="0" indent="0">
               <a:lnSpc>
                 <a:spcPct val="110000"/>
               </a:lnSpc>
@@ -4446,7 +4177,7 @@
       </p:sp>
       <p:graphicFrame>
         <p:nvGraphicFramePr>
-          <p:cNvPr id="3" name="Table 0"/>
+          <p:cNvPr id="6" name="Table 0"/>
           <p:cNvGraphicFramePr>
             <a:graphicFrameLocks noGrp="1"/>
           </p:cNvGraphicFramePr>
@@ -4460,15 +4191,27 @@
         </p:nvGraphicFramePr>
         <p:xfrm>
           <a:off x="548640" y="3657600"/>
-          <a:ext cx="5303520" cy="914400"/>
+          <a:ext cx="5303520" cy="1828800"/>
         </p:xfrm>
         <a:graphic>
           <a:graphicData uri="http://schemas.openxmlformats.org/drawingml/2006/table">
             <a:tbl>
               <a:tblPr/>
               <a:tblGrid>
-                <a:gridCol w="2651760"/>
-                <a:gridCol w="2651760"/>
+                <a:gridCol w="2651760">
+                  <a:extLst>
+                    <a:ext uri="{9D8B030D-6E8A-4147-A177-3AD203B41FA5}">
+                      <a16:colId xmlns:a16="http://schemas.microsoft.com/office/drawing/2014/main" val="20000"/>
+                    </a:ext>
+                  </a:extLst>
+                </a:gridCol>
+                <a:gridCol w="2651760">
+                  <a:extLst>
+                    <a:ext uri="{9D8B030D-6E8A-4147-A177-3AD203B41FA5}">
+                      <a16:colId xmlns:a16="http://schemas.microsoft.com/office/drawing/2014/main" val="20001"/>
+                    </a:ext>
+                  </a:extLst>
+                </a:gridCol>
               </a:tblGrid>
               <a:tr h="457200">
                 <a:tc>
@@ -4476,7 +4219,7 @@
                     <a:bodyPr/>
                     <a:lstStyle/>
                     <a:p>
-                      <a:pPr indent="0" marL="0">
+                      <a:pPr marL="0" indent="0">
                         <a:buNone/>
                       </a:pPr>
                       <a:r>
@@ -4497,7 +4240,7 @@
                       </a:endParaRPr>
                     </a:p>
                   </a:txBody>
-                  <a:tcPr marL="91440" marR="91440" marT="45720" marB="45720" anchor="ctr">
+                  <a:tcPr anchor="ctr">
                     <a:lnL w="12700" cap="flat" cmpd="sng" algn="ctr">
                       <a:solidFill>
                         <a:srgbClr val="E2E8F0"/>
@@ -4544,7 +4287,7 @@
                     <a:bodyPr/>
                     <a:lstStyle/>
                     <a:p>
-                      <a:pPr indent="0" marL="0">
+                      <a:pPr marL="0" indent="0">
                         <a:buNone/>
                       </a:pPr>
                       <a:r>
@@ -4565,7 +4308,7 @@
                       </a:endParaRPr>
                     </a:p>
                   </a:txBody>
-                  <a:tcPr marL="91440" marR="91440" marT="45720" marB="45720" anchor="ctr">
+                  <a:tcPr anchor="ctr">
                     <a:lnL w="12700" cap="flat" cmpd="sng" algn="ctr">
                       <a:solidFill>
                         <a:srgbClr val="E2E8F0"/>
@@ -4607,6 +4350,11 @@
                     </a:solidFill>
                   </a:tcPr>
                 </a:tc>
+                <a:extLst>
+                  <a:ext uri="{0D108BD9-81ED-4DB2-BD59-A6C34878D82A}">
+                    <a16:rowId xmlns:a16="http://schemas.microsoft.com/office/drawing/2014/main" val="10000"/>
+                  </a:ext>
+                </a:extLst>
               </a:tr>
               <a:tr h="457200">
                 <a:tc>
@@ -4614,7 +4362,7 @@
                     <a:bodyPr/>
                     <a:lstStyle/>
                     <a:p>
-                      <a:pPr indent="0" marL="0">
+                      <a:pPr marL="0" indent="0">
                         <a:buNone/>
                       </a:pPr>
                       <a:r>
@@ -4635,7 +4383,7 @@
                       </a:endParaRPr>
                     </a:p>
                   </a:txBody>
-                  <a:tcPr marL="91440" marR="91440" marT="45720" marB="45720" anchor="ctr">
+                  <a:tcPr anchor="ctr">
                     <a:lnL w="12700" cap="flat" cmpd="sng" algn="ctr">
                       <a:solidFill>
                         <a:srgbClr val="E2E8F0"/>
@@ -4682,7 +4430,7 @@
                     <a:bodyPr/>
                     <a:lstStyle/>
                     <a:p>
-                      <a:pPr indent="0" marL="0">
+                      <a:pPr marL="0" indent="0">
                         <a:buNone/>
                       </a:pPr>
                       <a:r>
@@ -4703,7 +4451,7 @@
                       </a:endParaRPr>
                     </a:p>
                   </a:txBody>
-                  <a:tcPr marL="91440" marR="91440" marT="45720" marB="45720" anchor="ctr">
+                  <a:tcPr anchor="ctr">
                     <a:lnL w="12700" cap="flat" cmpd="sng" algn="ctr">
                       <a:solidFill>
                         <a:srgbClr val="E2E8F0"/>
@@ -4745,6 +4493,11 @@
                     </a:solidFill>
                   </a:tcPr>
                 </a:tc>
+                <a:extLst>
+                  <a:ext uri="{0D108BD9-81ED-4DB2-BD59-A6C34878D82A}">
+                    <a16:rowId xmlns:a16="http://schemas.microsoft.com/office/drawing/2014/main" val="10001"/>
+                  </a:ext>
+                </a:extLst>
               </a:tr>
               <a:tr h="457200">
                 <a:tc>
@@ -4752,7 +4505,7 @@
                     <a:bodyPr/>
                     <a:lstStyle/>
                     <a:p>
-                      <a:pPr indent="0" marL="0">
+                      <a:pPr marL="0" indent="0">
                         <a:buNone/>
                       </a:pPr>
                       <a:r>
@@ -4773,7 +4526,7 @@
                       </a:endParaRPr>
                     </a:p>
                   </a:txBody>
-                  <a:tcPr marL="91440" marR="91440" marT="45720" marB="45720" anchor="ctr">
+                  <a:tcPr anchor="ctr">
                     <a:lnL w="12700" cap="flat" cmpd="sng" algn="ctr">
                       <a:solidFill>
                         <a:srgbClr val="E2E8F0"/>
@@ -4820,7 +4573,7 @@
                     <a:bodyPr/>
                     <a:lstStyle/>
                     <a:p>
-                      <a:pPr indent="0" marL="0">
+                      <a:pPr marL="0" indent="0">
                         <a:buNone/>
                       </a:pPr>
                       <a:r>
@@ -4841,7 +4594,7 @@
                       </a:endParaRPr>
                     </a:p>
                   </a:txBody>
-                  <a:tcPr marL="91440" marR="91440" marT="45720" marB="45720" anchor="ctr">
+                  <a:tcPr anchor="ctr">
                     <a:lnL w="12700" cap="flat" cmpd="sng" algn="ctr">
                       <a:solidFill>
                         <a:srgbClr val="E2E8F0"/>
@@ -4883,6 +4636,11 @@
                     </a:solidFill>
                   </a:tcPr>
                 </a:tc>
+                <a:extLst>
+                  <a:ext uri="{0D108BD9-81ED-4DB2-BD59-A6C34878D82A}">
+                    <a16:rowId xmlns:a16="http://schemas.microsoft.com/office/drawing/2014/main" val="10002"/>
+                  </a:ext>
+                </a:extLst>
               </a:tr>
               <a:tr h="457200">
                 <a:tc>
@@ -4890,7 +4648,7 @@
                     <a:bodyPr/>
                     <a:lstStyle/>
                     <a:p>
-                      <a:pPr indent="0" marL="0">
+                      <a:pPr marL="0" indent="0">
                         <a:buNone/>
                       </a:pPr>
                       <a:r>
@@ -4911,7 +4669,7 @@
                       </a:endParaRPr>
                     </a:p>
                   </a:txBody>
-                  <a:tcPr marL="91440" marR="91440" marT="45720" marB="45720" anchor="ctr">
+                  <a:tcPr anchor="ctr">
                     <a:lnL w="12700" cap="flat" cmpd="sng" algn="ctr">
                       <a:solidFill>
                         <a:srgbClr val="E2E8F0"/>
@@ -4958,7 +4716,7 @@
                     <a:bodyPr/>
                     <a:lstStyle/>
                     <a:p>
-                      <a:pPr indent="0" marL="0">
+                      <a:pPr marL="0" indent="0">
                         <a:buNone/>
                       </a:pPr>
                       <a:r>
@@ -4979,7 +4737,7 @@
                       </a:endParaRPr>
                     </a:p>
                   </a:txBody>
-                  <a:tcPr marL="91440" marR="91440" marT="45720" marB="45720" anchor="ctr">
+                  <a:tcPr anchor="ctr">
                     <a:lnL w="12700" cap="flat" cmpd="sng" algn="ctr">
                       <a:solidFill>
                         <a:srgbClr val="E2E8F0"/>
@@ -5021,6 +4779,11 @@
                     </a:solidFill>
                   </a:tcPr>
                 </a:tc>
+                <a:extLst>
+                  <a:ext uri="{0D108BD9-81ED-4DB2-BD59-A6C34878D82A}">
+                    <a16:rowId xmlns:a16="http://schemas.microsoft.com/office/drawing/2014/main" val="10003"/>
+                  </a:ext>
+                </a:extLst>
               </a:tr>
             </a:tbl>
           </a:graphicData>
@@ -5028,21 +4791,21 @@
       </p:graphicFrame>
       <p:pic>
         <p:nvPicPr>
-          <p:cNvPr id="7" name="Image 0" descr="/sessions/elegant-practical-davinci/mnt/04-Vision Detection/component-detection-yolo11/assets/01_data_capture.png">    </p:cNvPr>
+          <p:cNvPr id="7" name="Image 0" descr="/sessions/elegant-practical-davinci/mnt/04-Vision Detection/component-detection-yolo11/assets/01_data_capture.png"/>
           <p:cNvPicPr>
             <a:picLocks noChangeAspect="1"/>
           </p:cNvPicPr>
           <p:nvPr/>
         </p:nvPicPr>
         <p:blipFill>
-          <a:blip r:embed="rId1"/>
-          <a:srcRect l="0" r="0" t="0" b="0"/>
+          <a:blip r:embed="rId3"/>
+          <a:srcRect/>
           <a:stretch/>
         </p:blipFill>
         <p:spPr>
           <a:xfrm>
-            <a:off x="6126480" y="1280160"/>
-            <a:ext cx="5577840" cy="4389120"/>
+            <a:off x="5852160" y="1071797"/>
+            <a:ext cx="6339840" cy="4988726"/>
           </a:xfrm>
           <a:prstGeom prst="rect">
             <a:avLst/>
@@ -5065,6 +4828,7 @@
         <a:solidFill>
           <a:srgbClr val="FFFFFF"/>
         </a:solidFill>
+        <a:effectLst/>
       </p:bgPr>
     </p:bg>
     <p:spTree>
@@ -5122,7 +4886,7 @@
           <a:bodyPr wrap="square" lIns="0" tIns="0" rIns="0" bIns="0" rtlCol="0" anchor="ctr"/>
           <a:lstStyle/>
           <a:p>
-            <a:pPr indent="0" marL="0">
+            <a:pPr marL="0" indent="0">
               <a:buNone/>
             </a:pPr>
             <a:r>
@@ -5161,7 +4925,7 @@
           <a:bodyPr wrap="square" rtlCol="0" anchor="ctr"/>
           <a:lstStyle/>
           <a:p>
-            <a:pPr algn="r" indent="0" marL="0">
+            <a:pPr marL="0" indent="0" algn="r">
               <a:buNone/>
             </a:pPr>
             <a:r>
@@ -5181,15 +4945,15 @@
       </p:sp>
       <p:pic>
         <p:nvPicPr>
-          <p:cNvPr id="5" name="Image 0" descr="/sessions/elegant-practical-davinci/mnt/04-Vision Detection/component-detection-yolo11/assets/02_pipeline.png">    </p:cNvPr>
+          <p:cNvPr id="5" name="Image 0" descr="/sessions/elegant-practical-davinci/mnt/04-Vision Detection/component-detection-yolo11/assets/02_pipeline.png"/>
           <p:cNvPicPr>
             <a:picLocks noChangeAspect="1"/>
           </p:cNvPicPr>
           <p:nvPr/>
         </p:nvPicPr>
         <p:blipFill>
-          <a:blip r:embed="rId1"/>
-          <a:srcRect l="0" r="0" t="0" b="0"/>
+          <a:blip r:embed="rId3"/>
+          <a:srcRect/>
           <a:stretch/>
         </p:blipFill>
         <p:spPr>
@@ -5223,7 +4987,7 @@
           <a:bodyPr wrap="square" rtlCol="0" anchor="ctr"/>
           <a:lstStyle/>
           <a:p>
-            <a:pPr algn="ctr" indent="0" marL="0">
+            <a:pPr marL="0" indent="0" algn="ctr">
               <a:buNone/>
             </a:pPr>
             <a:r>
@@ -5257,6 +5021,7 @@
         <a:solidFill>
           <a:srgbClr val="FFFFFF"/>
         </a:solidFill>
+        <a:effectLst/>
       </p:bgPr>
     </p:bg>
     <p:spTree>
@@ -5314,7 +5079,7 @@
           <a:bodyPr wrap="square" lIns="0" tIns="0" rIns="0" bIns="0" rtlCol="0" anchor="ctr"/>
           <a:lstStyle/>
           <a:p>
-            <a:pPr indent="0" marL="0">
+            <a:pPr marL="0" indent="0">
               <a:buNone/>
             </a:pPr>
             <a:r>
@@ -5353,7 +5118,7 @@
           <a:bodyPr wrap="square" rtlCol="0" anchor="ctr"/>
           <a:lstStyle/>
           <a:p>
-            <a:pPr algn="r" indent="0" marL="0">
+            <a:pPr marL="0" indent="0" algn="r">
               <a:buNone/>
             </a:pPr>
             <a:r>
@@ -5373,15 +5138,15 @@
       </p:sp>
       <p:pic>
         <p:nvPicPr>
-          <p:cNvPr id="5" name="Image 0" descr="/sessions/elegant-practical-davinci/mnt/04-Vision Detection/component-detection-yolo11/assets/01_data_capture.png">    </p:cNvPr>
+          <p:cNvPr id="5" name="Image 0" descr="/sessions/elegant-practical-davinci/mnt/04-Vision Detection/component-detection-yolo11/assets/01_data_capture.png"/>
           <p:cNvPicPr>
             <a:picLocks noChangeAspect="1"/>
           </p:cNvPicPr>
           <p:nvPr/>
         </p:nvPicPr>
         <p:blipFill>
-          <a:blip r:embed="rId1"/>
-          <a:srcRect l="0" r="0" t="0" b="0"/>
+          <a:blip r:embed="rId3"/>
+          <a:srcRect/>
           <a:stretch/>
         </p:blipFill>
         <p:spPr>
@@ -5415,7 +5180,7 @@
           <a:bodyPr wrap="square" rtlCol="0" anchor="t"/>
           <a:lstStyle/>
           <a:p>
-            <a:pPr indent="0" marL="0">
+            <a:pPr marL="0" indent="0">
               <a:lnSpc>
                 <a:spcPct val="115000"/>
               </a:lnSpc>
@@ -5561,6 +5326,7 @@
         <a:solidFill>
           <a:srgbClr val="FFFFFF"/>
         </a:solidFill>
+        <a:effectLst/>
       </p:bgPr>
     </p:bg>
     <p:spTree>
@@ -5618,7 +5384,7 @@
           <a:bodyPr wrap="square" lIns="0" tIns="0" rIns="0" bIns="0" rtlCol="0" anchor="ctr"/>
           <a:lstStyle/>
           <a:p>
-            <a:pPr indent="0" marL="0">
+            <a:pPr marL="0" indent="0">
               <a:buNone/>
             </a:pPr>
             <a:r>
@@ -5657,7 +5423,7 @@
           <a:bodyPr wrap="square" rtlCol="0" anchor="ctr"/>
           <a:lstStyle/>
           <a:p>
-            <a:pPr algn="r" indent="0" marL="0">
+            <a:pPr marL="0" indent="0" algn="r">
               <a:buNone/>
             </a:pPr>
             <a:r>
@@ -5696,7 +5462,7 @@
           <a:bodyPr wrap="square" rtlCol="0" anchor="t"/>
           <a:lstStyle/>
           <a:p>
-            <a:pPr indent="0" marL="0">
+            <a:pPr marL="0" indent="0">
               <a:lnSpc>
                 <a:spcPct val="110000"/>
               </a:lnSpc>
@@ -5720,7 +5486,7 @@
             <a:endParaRPr lang="en-US" sz="1500" dirty="0"/>
           </a:p>
           <a:p>
-            <a:pPr indent="0" marL="0">
+            <a:pPr marL="0" indent="0">
               <a:lnSpc>
                 <a:spcPct val="110000"/>
               </a:lnSpc>
@@ -5782,7 +5548,7 @@
           <a:bodyPr wrap="square" rtlCol="0" anchor="ctr"/>
           <a:lstStyle/>
           <a:p>
-            <a:pPr indent="0" marL="0">
+            <a:pPr marL="0" indent="0">
               <a:lnSpc>
                 <a:spcPct val="120000"/>
               </a:lnSpc>
@@ -5802,7 +5568,7 @@
             <a:endParaRPr lang="en-US" sz="1250" dirty="0"/>
           </a:p>
           <a:p>
-            <a:pPr indent="0" marL="0">
+            <a:pPr marL="0" indent="0">
               <a:lnSpc>
                 <a:spcPct val="120000"/>
               </a:lnSpc>
@@ -5844,7 +5610,7 @@
           <a:bodyPr wrap="square" rtlCol="0" anchor="ctr"/>
           <a:lstStyle/>
           <a:p>
-            <a:pPr indent="0" marL="0">
+            <a:pPr marL="0" indent="0">
               <a:buNone/>
             </a:pPr>
             <a:r>
@@ -5878,6 +5644,7 @@
         <a:solidFill>
           <a:srgbClr val="FFFFFF"/>
         </a:solidFill>
+        <a:effectLst/>
       </p:bgPr>
     </p:bg>
     <p:spTree>
@@ -5935,7 +5702,7 @@
           <a:bodyPr wrap="square" lIns="0" tIns="0" rIns="0" bIns="0" rtlCol="0" anchor="ctr"/>
           <a:lstStyle/>
           <a:p>
-            <a:pPr indent="0" marL="0">
+            <a:pPr marL="0" indent="0">
               <a:buNone/>
             </a:pPr>
             <a:r>
@@ -5974,7 +5741,7 @@
           <a:bodyPr wrap="square" rtlCol="0" anchor="ctr"/>
           <a:lstStyle/>
           <a:p>
-            <a:pPr algn="r" indent="0" marL="0">
+            <a:pPr marL="0" indent="0" algn="r">
               <a:buNone/>
             </a:pPr>
             <a:r>
@@ -5994,15 +5761,15 @@
       </p:sp>
       <p:pic>
         <p:nvPicPr>
-          <p:cNvPr id="5" name="Image 0" descr="/sessions/elegant-practical-davinci/mnt/04-Vision Detection/component-detection-yolo11/assets/training_map.png">    </p:cNvPr>
+          <p:cNvPr id="5" name="Image 0" descr="/sessions/elegant-practical-davinci/mnt/04-Vision Detection/component-detection-yolo11/assets/training_map.png"/>
           <p:cNvPicPr>
             <a:picLocks noChangeAspect="1"/>
           </p:cNvPicPr>
           <p:nvPr/>
         </p:nvPicPr>
         <p:blipFill>
-          <a:blip r:embed="rId1"/>
-          <a:srcRect l="0" r="0" t="0" b="0"/>
+          <a:blip r:embed="rId3"/>
+          <a:srcRect/>
           <a:stretch/>
         </p:blipFill>
         <p:spPr>
@@ -6017,15 +5784,15 @@
       </p:pic>
       <p:pic>
         <p:nvPicPr>
-          <p:cNvPr id="6" name="Image 1" descr="/sessions/elegant-practical-davinci/mnt/04-Vision Detection/component-detection-yolo11/assets/training_time.png">    </p:cNvPr>
+          <p:cNvPr id="6" name="Image 1" descr="/sessions/elegant-practical-davinci/mnt/04-Vision Detection/component-detection-yolo11/assets/training_time.png"/>
           <p:cNvPicPr>
             <a:picLocks noChangeAspect="1"/>
           </p:cNvPicPr>
           <p:nvPr/>
         </p:nvPicPr>
         <p:blipFill>
-          <a:blip r:embed="rId2"/>
-          <a:srcRect l="0" r="0" t="0" b="0"/>
+          <a:blip r:embed="rId4"/>
+          <a:srcRect/>
           <a:stretch/>
         </p:blipFill>
         <p:spPr>
@@ -6059,7 +5826,7 @@
           <a:bodyPr wrap="square" rtlCol="0" anchor="ctr"/>
           <a:lstStyle/>
           <a:p>
-            <a:pPr algn="ctr" indent="0" marL="0">
+            <a:pPr marL="0" indent="0" algn="ctr">
               <a:buNone/>
             </a:pPr>
             <a:r>
@@ -6093,6 +5860,7 @@
         <a:solidFill>
           <a:srgbClr val="FFFFFF"/>
         </a:solidFill>
+        <a:effectLst/>
       </p:bgPr>
     </p:bg>
     <p:spTree>
@@ -6150,7 +5918,7 @@
           <a:bodyPr wrap="square" lIns="0" tIns="0" rIns="0" bIns="0" rtlCol="0" anchor="ctr"/>
           <a:lstStyle/>
           <a:p>
-            <a:pPr indent="0" marL="0">
+            <a:pPr marL="0" indent="0">
               <a:buNone/>
             </a:pPr>
             <a:r>
@@ -6189,7 +5957,7 @@
           <a:bodyPr wrap="square" rtlCol="0" anchor="ctr"/>
           <a:lstStyle/>
           <a:p>
-            <a:pPr algn="r" indent="0" marL="0">
+            <a:pPr marL="0" indent="0" algn="r">
               <a:buNone/>
             </a:pPr>
             <a:r>
@@ -6209,15 +5977,15 @@
       </p:sp>
       <p:pic>
         <p:nvPicPr>
-          <p:cNvPr id="5" name="Image 0" descr="/sessions/elegant-practical-davinci/mnt/04-Vision Detection/component-detection-yolo11/results/confusion_matrix_normalized.png">    </p:cNvPr>
+          <p:cNvPr id="5" name="Image 0" descr="/sessions/elegant-practical-davinci/mnt/04-Vision Detection/component-detection-yolo11/results/confusion_matrix_normalized.png"/>
           <p:cNvPicPr>
             <a:picLocks noChangeAspect="1"/>
           </p:cNvPicPr>
           <p:nvPr/>
         </p:nvPicPr>
         <p:blipFill>
-          <a:blip r:embed="rId1"/>
-          <a:srcRect l="0" r="0" t="0" b="0"/>
+          <a:blip r:embed="rId3"/>
+          <a:srcRect/>
           <a:stretch/>
         </p:blipFill>
         <p:spPr>
@@ -6232,15 +6000,15 @@
       </p:pic>
       <p:pic>
         <p:nvPicPr>
-          <p:cNvPr id="6" name="Image 1" descr="/sessions/elegant-practical-davinci/mnt/04-Vision Detection/component-detection-yolo11/results/BoxPR_curve.png">    </p:cNvPr>
+          <p:cNvPr id="6" name="Image 1" descr="/sessions/elegant-practical-davinci/mnt/04-Vision Detection/component-detection-yolo11/results/BoxPR_curve.png"/>
           <p:cNvPicPr>
             <a:picLocks noChangeAspect="1"/>
           </p:cNvPicPr>
           <p:nvPr/>
         </p:nvPicPr>
         <p:blipFill>
-          <a:blip r:embed="rId2"/>
-          <a:srcRect l="0" r="0" t="0" b="0"/>
+          <a:blip r:embed="rId4"/>
+          <a:srcRect/>
           <a:stretch/>
         </p:blipFill>
         <p:spPr>
@@ -6269,6 +6037,7 @@
         <a:solidFill>
           <a:srgbClr val="FFFFFF"/>
         </a:solidFill>
+        <a:effectLst/>
       </p:bgPr>
     </p:bg>
     <p:spTree>
@@ -6326,7 +6095,7 @@
           <a:bodyPr wrap="square" lIns="0" tIns="0" rIns="0" bIns="0" rtlCol="0" anchor="ctr"/>
           <a:lstStyle/>
           <a:p>
-            <a:pPr indent="0" marL="0">
+            <a:pPr marL="0" indent="0">
               <a:buNone/>
             </a:pPr>
             <a:r>
@@ -6365,7 +6134,7 @@
           <a:bodyPr wrap="square" rtlCol="0" anchor="ctr"/>
           <a:lstStyle/>
           <a:p>
-            <a:pPr algn="r" indent="0" marL="0">
+            <a:pPr marL="0" indent="0" algn="r">
               <a:buNone/>
             </a:pPr>
             <a:r>
@@ -6385,15 +6154,15 @@
       </p:sp>
       <p:pic>
         <p:nvPicPr>
-          <p:cNvPr id="5" name="Image 0" descr="/sessions/elegant-practical-davinci/mnt/04-Vision Detection/component-detection-yolo11/assets/fps_compare.png">    </p:cNvPr>
+          <p:cNvPr id="5" name="Image 0" descr="/sessions/elegant-practical-davinci/mnt/04-Vision Detection/component-detection-yolo11/assets/fps_compare.png"/>
           <p:cNvPicPr>
             <a:picLocks noChangeAspect="1"/>
           </p:cNvPicPr>
           <p:nvPr/>
         </p:nvPicPr>
         <p:blipFill>
-          <a:blip r:embed="rId1"/>
-          <a:srcRect l="0" r="0" t="0" b="0"/>
+          <a:blip r:embed="rId3"/>
+          <a:srcRect/>
           <a:stretch/>
         </p:blipFill>
         <p:spPr>
@@ -6427,7 +6196,7 @@
           <a:bodyPr wrap="square" rtlCol="0" anchor="t"/>
           <a:lstStyle/>
           <a:p>
-            <a:pPr indent="0" marL="0">
+            <a:pPr marL="0" indent="0">
               <a:lnSpc>
                 <a:spcPct val="115000"/>
               </a:lnSpc>
@@ -6514,7 +6283,7 @@
             <a:endParaRPr lang="en-US" sz="1500" dirty="0"/>
           </a:p>
           <a:p>
-            <a:pPr indent="0" marL="0">
+            <a:pPr marL="0" indent="0">
               <a:lnSpc>
                 <a:spcPct val="115000"/>
               </a:lnSpc>
@@ -6551,6 +6320,7 @@
         <a:solidFill>
           <a:srgbClr val="FFFFFF"/>
         </a:solidFill>
+        <a:effectLst/>
       </p:bgPr>
     </p:bg>
     <p:spTree>
@@ -6608,7 +6378,7 @@
           <a:bodyPr wrap="square" lIns="0" tIns="0" rIns="0" bIns="0" rtlCol="0" anchor="ctr"/>
           <a:lstStyle/>
           <a:p>
-            <a:pPr indent="0" marL="0">
+            <a:pPr marL="0" indent="0">
               <a:buNone/>
             </a:pPr>
             <a:r>
@@ -6647,7 +6417,7 @@
           <a:bodyPr wrap="square" rtlCol="0" anchor="ctr"/>
           <a:lstStyle/>
           <a:p>
-            <a:pPr algn="r" indent="0" marL="0">
+            <a:pPr marL="0" indent="0" algn="r">
               <a:buNone/>
             </a:pPr>
             <a:r>
@@ -6667,15 +6437,15 @@
       </p:sp>
       <p:pic>
         <p:nvPicPr>
-          <p:cNvPr id="5" name="Image 0" descr="/sessions/elegant-practical-davinci/mnt/04-Vision Detection/component-detection-yolo11/assets/fps_timeline.png">    </p:cNvPr>
+          <p:cNvPr id="5" name="Image 0" descr="/sessions/elegant-practical-davinci/mnt/04-Vision Detection/component-detection-yolo11/assets/fps_timeline.png"/>
           <p:cNvPicPr>
             <a:picLocks noChangeAspect="1"/>
           </p:cNvPicPr>
           <p:nvPr/>
         </p:nvPicPr>
         <p:blipFill>
-          <a:blip r:embed="rId1"/>
-          <a:srcRect l="0" r="0" t="0" b="0"/>
+          <a:blip r:embed="rId3"/>
+          <a:srcRect/>
           <a:stretch/>
         </p:blipFill>
         <p:spPr>
@@ -6989,4 +6759,299 @@
     </a:ext>
   </a:extLst>
 </a:theme>
+</file>
+
+<file path=ppt/theme/theme2.xml><?xml version="1.0" encoding="utf-8"?>
+<a:theme xmlns:a="http://schemas.openxmlformats.org/drawingml/2006/main" name="Office Theme">
+  <a:themeElements>
+    <a:clrScheme name="Office">
+      <a:dk1>
+        <a:sysClr val="windowText" lastClr="000000"/>
+      </a:dk1>
+      <a:lt1>
+        <a:sysClr val="window" lastClr="FFFFFF"/>
+      </a:lt1>
+      <a:dk2>
+        <a:srgbClr val="44546A"/>
+      </a:dk2>
+      <a:lt2>
+        <a:srgbClr val="E7E6E6"/>
+      </a:lt2>
+      <a:accent1>
+        <a:srgbClr val="4472C4"/>
+      </a:accent1>
+      <a:accent2>
+        <a:srgbClr val="ED7D31"/>
+      </a:accent2>
+      <a:accent3>
+        <a:srgbClr val="A5A5A5"/>
+      </a:accent3>
+      <a:accent4>
+        <a:srgbClr val="FFC000"/>
+      </a:accent4>
+      <a:accent5>
+        <a:srgbClr val="5B9BD5"/>
+      </a:accent5>
+      <a:accent6>
+        <a:srgbClr val="70AD47"/>
+      </a:accent6>
+      <a:hlink>
+        <a:srgbClr val="0563C1"/>
+      </a:hlink>
+      <a:folHlink>
+        <a:srgbClr val="954F72"/>
+      </a:folHlink>
+    </a:clrScheme>
+    <a:fontScheme name="Office">
+      <a:majorFont>
+        <a:latin typeface="Calibri Light" panose="020F0302020204030204"/>
+        <a:ea typeface=""/>
+        <a:cs typeface=""/>
+        <a:font script="Jpan" typeface="游ゴシック Light"/>
+        <a:font script="Hang" typeface="맑은 고딕"/>
+        <a:font script="Hans" typeface="等线 Light"/>
+        <a:font script="Hant" typeface="新細明體"/>
+        <a:font script="Arab" typeface="Times New Roman"/>
+        <a:font script="Hebr" typeface="Times New Roman"/>
+        <a:font script="Thai" typeface="Angsana New"/>
+        <a:font script="Ethi" typeface="Nyala"/>
+        <a:font script="Beng" typeface="Vrinda"/>
+        <a:font script="Gujr" typeface="Shruti"/>
+        <a:font script="Khmr" typeface="MoolBoran"/>
+        <a:font script="Knda" typeface="Tunga"/>
+        <a:font script="Guru" typeface="Raavi"/>
+        <a:font script="Cans" typeface="Euphemia"/>
+        <a:font script="Cher" typeface="Plantagenet Cherokee"/>
+        <a:font script="Yiii" typeface="Microsoft Yi Baiti"/>
+        <a:font script="Tibt" typeface="Microsoft Himalaya"/>
+        <a:font script="Thaa" typeface="MV Boli"/>
+        <a:font script="Deva" typeface="Mangal"/>
+        <a:font script="Telu" typeface="Gautami"/>
+        <a:font script="Taml" typeface="Latha"/>
+        <a:font script="Syrc" typeface="Estrangelo Edessa"/>
+        <a:font script="Orya" typeface="Kalinga"/>
+        <a:font script="Mlym" typeface="Kartika"/>
+        <a:font script="Laoo" typeface="DokChampa"/>
+        <a:font script="Sinh" typeface="Iskoola Pota"/>
+        <a:font script="Mong" typeface="Mongolian Baiti"/>
+        <a:font script="Viet" typeface="Times New Roman"/>
+        <a:font script="Uigh" typeface="Microsoft Uighur"/>
+        <a:font script="Geor" typeface="Sylfaen"/>
+        <a:font script="Armn" typeface="Arial"/>
+        <a:font script="Bugi" typeface="Leelawadee UI"/>
+        <a:font script="Bopo" typeface="Microsoft JhengHei"/>
+        <a:font script="Java" typeface="Javanese Text"/>
+        <a:font script="Lisu" typeface="Segoe UI"/>
+        <a:font script="Mymr" typeface="Myanmar Text"/>
+        <a:font script="Nkoo" typeface="Ebrima"/>
+        <a:font script="Olck" typeface="Nirmala UI"/>
+        <a:font script="Osma" typeface="Ebrima"/>
+        <a:font script="Phag" typeface="Phagspa"/>
+        <a:font script="Syrn" typeface="Estrangelo Edessa"/>
+        <a:font script="Syrj" typeface="Estrangelo Edessa"/>
+        <a:font script="Syre" typeface="Estrangelo Edessa"/>
+        <a:font script="Sora" typeface="Nirmala UI"/>
+        <a:font script="Tale" typeface="Microsoft Tai Le"/>
+        <a:font script="Talu" typeface="Microsoft New Tai Lue"/>
+        <a:font script="Tfng" typeface="Ebrima"/>
+      </a:majorFont>
+      <a:minorFont>
+        <a:latin typeface="Calibri" panose="020F0502020204030204"/>
+        <a:ea typeface=""/>
+        <a:cs typeface=""/>
+        <a:font script="Jpan" typeface="游ゴシック"/>
+        <a:font script="Hang" typeface="맑은 고딕"/>
+        <a:font script="Hans" typeface="等线"/>
+        <a:font script="Hant" typeface="新細明體"/>
+        <a:font script="Arab" typeface="Arial"/>
+        <a:font script="Hebr" typeface="Arial"/>
+        <a:font script="Thai" typeface="Cordia New"/>
+        <a:font script="Ethi" typeface="Nyala"/>
+        <a:font script="Beng" typeface="Vrinda"/>
+        <a:font script="Gujr" typeface="Shruti"/>
+        <a:font script="Khmr" typeface="DaunPenh"/>
+        <a:font script="Knda" typeface="Tunga"/>
+        <a:font script="Guru" typeface="Raavi"/>
+        <a:font script="Cans" typeface="Euphemia"/>
+        <a:font script="Cher" typeface="Plantagenet Cherokee"/>
+        <a:font script="Yiii" typeface="Microsoft Yi Baiti"/>
+        <a:font script="Tibt" typeface="Microsoft Himalaya"/>
+        <a:font script="Thaa" typeface="MV Boli"/>
+        <a:font script="Deva" typeface="Mangal"/>
+        <a:font script="Telu" typeface="Gautami"/>
+        <a:font script="Taml" typeface="Latha"/>
+        <a:font script="Syrc" typeface="Estrangelo Edessa"/>
+        <a:font script="Orya" typeface="Kalinga"/>
+        <a:font script="Mlym" typeface="Kartika"/>
+        <a:font script="Laoo" typeface="DokChampa"/>
+        <a:font script="Sinh" typeface="Iskoola Pota"/>
+        <a:font script="Mong" typeface="Mongolian Baiti"/>
+        <a:font script="Viet" typeface="Arial"/>
+        <a:font script="Uigh" typeface="Microsoft Uighur"/>
+        <a:font script="Geor" typeface="Sylfaen"/>
+        <a:font script="Armn" typeface="Arial"/>
+        <a:font script="Bugi" typeface="Leelawadee UI"/>
+        <a:font script="Bopo" typeface="Microsoft JhengHei"/>
+        <a:font script="Java" typeface="Javanese Text"/>
+        <a:font script="Lisu" typeface="Segoe UI"/>
+        <a:font script="Mymr" typeface="Myanmar Text"/>
+        <a:font script="Nkoo" typeface="Ebrima"/>
+        <a:font script="Olck" typeface="Nirmala UI"/>
+        <a:font script="Osma" typeface="Ebrima"/>
+        <a:font script="Phag" typeface="Phagspa"/>
+        <a:font script="Syrn" typeface="Estrangelo Edessa"/>
+        <a:font script="Syrj" typeface="Estrangelo Edessa"/>
+        <a:font script="Syre" typeface="Estrangelo Edessa"/>
+        <a:font script="Sora" typeface="Nirmala UI"/>
+        <a:font script="Tale" typeface="Microsoft Tai Le"/>
+        <a:font script="Talu" typeface="Microsoft New Tai Lue"/>
+        <a:font script="Tfng" typeface="Ebrima"/>
+      </a:minorFont>
+    </a:fontScheme>
+    <a:fmtScheme name="Office">
+      <a:fillStyleLst>
+        <a:solidFill>
+          <a:schemeClr val="phClr"/>
+        </a:solidFill>
+        <a:gradFill rotWithShape="1">
+          <a:gsLst>
+            <a:gs pos="0">
+              <a:schemeClr val="phClr">
+                <a:lumMod val="110000"/>
+                <a:satMod val="105000"/>
+                <a:tint val="67000"/>
+              </a:schemeClr>
+            </a:gs>
+            <a:gs pos="50000">
+              <a:schemeClr val="phClr">
+                <a:lumMod val="105000"/>
+                <a:satMod val="103000"/>
+                <a:tint val="73000"/>
+              </a:schemeClr>
+            </a:gs>
+            <a:gs pos="100000">
+              <a:schemeClr val="phClr">
+                <a:lumMod val="105000"/>
+                <a:satMod val="109000"/>
+                <a:tint val="81000"/>
+              </a:schemeClr>
+            </a:gs>
+          </a:gsLst>
+          <a:lin ang="5400000" scaled="0"/>
+        </a:gradFill>
+        <a:gradFill rotWithShape="1">
+          <a:gsLst>
+            <a:gs pos="0">
+              <a:schemeClr val="phClr">
+                <a:satMod val="103000"/>
+                <a:lumMod val="102000"/>
+                <a:tint val="94000"/>
+              </a:schemeClr>
+            </a:gs>
+            <a:gs pos="50000">
+              <a:schemeClr val="phClr">
+                <a:satMod val="110000"/>
+                <a:lumMod val="100000"/>
+                <a:shade val="100000"/>
+              </a:schemeClr>
+            </a:gs>
+            <a:gs pos="100000">
+              <a:schemeClr val="phClr">
+                <a:lumMod val="99000"/>
+                <a:satMod val="120000"/>
+                <a:shade val="78000"/>
+              </a:schemeClr>
+            </a:gs>
+          </a:gsLst>
+          <a:lin ang="5400000" scaled="0"/>
+        </a:gradFill>
+      </a:fillStyleLst>
+      <a:lnStyleLst>
+        <a:ln w="6350" cap="flat" cmpd="sng" algn="ctr">
+          <a:solidFill>
+            <a:schemeClr val="phClr"/>
+          </a:solidFill>
+          <a:prstDash val="solid"/>
+          <a:miter lim="800000"/>
+        </a:ln>
+        <a:ln w="12700" cap="flat" cmpd="sng" algn="ctr">
+          <a:solidFill>
+            <a:schemeClr val="phClr"/>
+          </a:solidFill>
+          <a:prstDash val="solid"/>
+          <a:miter lim="800000"/>
+        </a:ln>
+        <a:ln w="19050" cap="flat" cmpd="sng" algn="ctr">
+          <a:solidFill>
+            <a:schemeClr val="phClr"/>
+          </a:solidFill>
+          <a:prstDash val="solid"/>
+          <a:miter lim="800000"/>
+        </a:ln>
+      </a:lnStyleLst>
+      <a:effectStyleLst>
+        <a:effectStyle>
+          <a:effectLst/>
+        </a:effectStyle>
+        <a:effectStyle>
+          <a:effectLst/>
+        </a:effectStyle>
+        <a:effectStyle>
+          <a:effectLst>
+            <a:outerShdw blurRad="57150" dist="19050" dir="5400000" algn="ctr" rotWithShape="0">
+              <a:srgbClr val="000000">
+                <a:alpha val="63000"/>
+              </a:srgbClr>
+            </a:outerShdw>
+          </a:effectLst>
+        </a:effectStyle>
+      </a:effectStyleLst>
+      <a:bgFillStyleLst>
+        <a:solidFill>
+          <a:schemeClr val="phClr"/>
+        </a:solidFill>
+        <a:solidFill>
+          <a:schemeClr val="phClr">
+            <a:tint val="95000"/>
+            <a:satMod val="170000"/>
+          </a:schemeClr>
+        </a:solidFill>
+        <a:gradFill rotWithShape="1">
+          <a:gsLst>
+            <a:gs pos="0">
+              <a:schemeClr val="phClr">
+                <a:tint val="93000"/>
+                <a:satMod val="150000"/>
+                <a:shade val="98000"/>
+                <a:lumMod val="102000"/>
+              </a:schemeClr>
+            </a:gs>
+            <a:gs pos="50000">
+              <a:schemeClr val="phClr">
+                <a:tint val="98000"/>
+                <a:satMod val="130000"/>
+                <a:shade val="90000"/>
+                <a:lumMod val="103000"/>
+              </a:schemeClr>
+            </a:gs>
+            <a:gs pos="100000">
+              <a:schemeClr val="phClr">
+                <a:shade val="63000"/>
+                <a:satMod val="120000"/>
+              </a:schemeClr>
+            </a:gs>
+          </a:gsLst>
+          <a:lin ang="5400000" scaled="0"/>
+        </a:gradFill>
+      </a:bgFillStyleLst>
+    </a:fmtScheme>
+  </a:themeElements>
+  <a:objectDefaults/>
+  <a:extraClrSchemeLst/>
+  <a:extLst>
+    <a:ext uri="{05A4C25C-085E-4340-85A3-A5531E510DB2}">
+      <thm15:themeFamily xmlns:thm15="http://schemas.microsoft.com/office/thememl/2012/main" name="Office Theme" id="{62F939B6-93AF-4DB8-9C6B-D6C7DFDC589F}" vid="{4A3C46E8-61CC-4603-A589-7422A47A8E4A}"/>
+    </a:ext>
+  </a:extLst>
+</a:theme>
 </file>
</xml_diff>